<commit_message>
Refresh decks with syfr.live company name and plate
Co-Authored-By: Claude Sonnet 5.5 <noreply@anthropic.com>
Claude-Session: https://claude.ai/code/session_01DwMvXGQxcAxL4J7CRLnDzp
</commit_message>
<xml_diff>
--- a/ev-registry/docs/EV-Pehchaan-deck-mint.pptx
+++ b/ev-registry/docs/EV-Pehchaan-deck-mint.pptx
@@ -118,7 +118,7 @@
   <p:extLst>
     <p:ext uri="{521415D9-36F7-43E2-AB2F-B90AF26B5E84}">
       <p14:sectionLst xmlns:p14="http://schemas.microsoft.com/office/powerpoint/2010/main">
-        <p14:section name="Overview" id="{57e610da-7265-d4e7-40f9-6bd3298ad096}">
+        <p14:section name="Overview" id="{0db3ae14-1eec-ca05-dd63-85983d16020f}">
           <p14:sldIdLst>
             <p14:sldId id="256"/>
             <p14:sldId id="257"/>
@@ -126,7 +126,7 @@
             <p14:sldId id="259"/>
           </p14:sldIdLst>
         </p14:section>
-        <p14:section name="Company" id="{c10a802c-92bc-8964-d635-7f410f381396}">
+        <p14:section name="Company" id="{f43fd973-0b53-34ec-91e8-f606cd189f8e}">
           <p14:sldIdLst>
             <p14:sldId id="260"/>
             <p14:sldId id="261"/>
@@ -134,12 +134,12 @@
             <p14:sldId id="263"/>
           </p14:sldIdLst>
         </p14:section>
-        <p14:section name="Dealer and owner" id="{29b0b6d9-70eb-14bb-88e1-d6dff660306c}">
+        <p14:section name="Dealer and owner" id="{c5183f8b-a26c-02da-59c9-13eadf721f94}">
           <p14:sldIdLst>
             <p14:sldId id="264"/>
           </p14:sldIdLst>
         </p14:section>
-        <p14:section name="Next" id="{4ef265c4-041b-7122-3a9f-3f31c4b87c67}">
+        <p14:section name="Next" id="{31eef51e-6a96-0bea-8868-b51306f6e1d8}">
           <p14:sldIdLst>
             <p14:sldId id="265"/>
             <p14:sldId id="266"/>
@@ -3312,7 +3312,7 @@
                 <a:ea typeface="Outfit" pitchFamily="34" charset="-122"/>
                 <a:cs typeface="Outfit" pitchFamily="34" charset="-120"/>
               </a:rPr>
-              <a:t>PRODUCT</a:t>
+              <a:t>COMPANY</a:t>
             </a:r>
             <a:endParaRPr lang="en-US" sz="1000" dirty="0"/>
           </a:p>
@@ -3351,7 +3351,7 @@
                 <a:ea typeface="Outfit" pitchFamily="34" charset="-122"/>
                 <a:cs typeface="Outfit" pitchFamily="34" charset="-120"/>
               </a:rPr>
-              <a:t>Registry for small e-bikes</a:t>
+              <a:t>syfr.live</a:t>
             </a:r>
             <a:endParaRPr lang="en-US" sz="1300" dirty="0"/>
           </a:p>
@@ -3365,7 +3365,7 @@
         </p:nvSpPr>
         <p:spPr>
           <a:xfrm>
-            <a:off x="3703320" y="5669280"/>
+            <a:off x="2971800" y="5669280"/>
             <a:ext cx="2743200" cy="228600"/>
           </a:xfrm>
           <a:prstGeom prst="rect">
@@ -3390,7 +3390,7 @@
                 <a:ea typeface="Outfit" pitchFamily="34" charset="-122"/>
                 <a:cs typeface="Outfit" pitchFamily="34" charset="-120"/>
               </a:rPr>
-              <a:t>DATA</a:t>
+              <a:t>PRODUCT</a:t>
             </a:r>
             <a:endParaRPr lang="en-US" sz="1000" dirty="0"/>
           </a:p>
@@ -3404,7 +3404,85 @@
         </p:nvSpPr>
         <p:spPr>
           <a:xfrm>
-            <a:off x="3703320" y="5916168"/>
+            <a:off x="2971800" y="5916168"/>
+            <a:ext cx="2743200" cy="274320"/>
+          </a:xfrm>
+          <a:prstGeom prst="rect">
+            <a:avLst/>
+          </a:prstGeom>
+          <a:noFill/>
+          <a:ln/>
+        </p:spPr>
+        <p:txBody>
+          <a:bodyPr wrap="square" lIns="0" tIns="0" rIns="0" bIns="0" rtlCol="0" anchor="t"/>
+          <a:lstStyle/>
+          <a:p>
+            <a:pPr indent="0" marL="0">
+              <a:buNone/>
+            </a:pPr>
+            <a:r>
+              <a:rPr lang="en-US" sz="1300" dirty="0">
+                <a:solidFill>
+                  <a:schemeClr val="tx1"/>
+                </a:solidFill>
+                <a:latin typeface="Outfit" pitchFamily="34" charset="0"/>
+                <a:ea typeface="Outfit" pitchFamily="34" charset="-122"/>
+                <a:cs typeface="Outfit" pitchFamily="34" charset="-120"/>
+              </a:rPr>
+              <a:t>EV Pehchaan registry</a:t>
+            </a:r>
+            <a:endParaRPr lang="en-US" sz="1300" dirty="0"/>
+          </a:p>
+        </p:txBody>
+      </p:sp>
+      <p:sp>
+        <p:nvSpPr>
+          <p:cNvPr id="11" name="Text"/>
+          <p:cNvSpPr txBox="1"/>
+          <p:nvPr/>
+        </p:nvSpPr>
+        <p:spPr>
+          <a:xfrm>
+            <a:off x="5349240" y="5669280"/>
+            <a:ext cx="2743200" cy="228600"/>
+          </a:xfrm>
+          <a:prstGeom prst="rect">
+            <a:avLst/>
+          </a:prstGeom>
+          <a:noFill/>
+          <a:ln/>
+        </p:spPr>
+        <p:txBody>
+          <a:bodyPr wrap="square" lIns="0" tIns="0" rIns="0" bIns="0" rtlCol="0" anchor="t"/>
+          <a:lstStyle/>
+          <a:p>
+            <a:pPr indent="0" marL="0">
+              <a:buNone/>
+            </a:pPr>
+            <a:r>
+              <a:rPr lang="en-US" sz="1000" b="1" spc="100" kern="0" dirty="0">
+                <a:solidFill>
+                  <a:schemeClr val="accent2"/>
+                </a:solidFill>
+                <a:latin typeface="Outfit" pitchFamily="34" charset="0"/>
+                <a:ea typeface="Outfit" pitchFamily="34" charset="-122"/>
+                <a:cs typeface="Outfit" pitchFamily="34" charset="-120"/>
+              </a:rPr>
+              <a:t>DATA</a:t>
+            </a:r>
+            <a:endParaRPr lang="en-US" sz="1000" dirty="0"/>
+          </a:p>
+        </p:txBody>
+      </p:sp>
+      <p:sp>
+        <p:nvSpPr>
+          <p:cNvPr id="12" name="Text"/>
+          <p:cNvSpPr txBox="1"/>
+          <p:nvPr/>
+        </p:nvSpPr>
+        <p:spPr>
+          <a:xfrm>
+            <a:off x="5349240" y="5916168"/>
             <a:ext cx="2743200" cy="274320"/>
           </a:xfrm>
           <a:prstGeom prst="rect">
@@ -6432,7 +6510,7 @@
         </p:blipFill>
         <p:spPr>
           <a:xfrm>
-            <a:off x="6309360" y="4178808"/>
+            <a:off x="6309360" y="4041648"/>
             <a:ext cx="256032" cy="256032"/>
           </a:xfrm>
           <a:prstGeom prst="rect">
@@ -6450,7 +6528,7 @@
         </p:nvSpPr>
         <p:spPr>
           <a:xfrm>
-            <a:off x="6720840" y="4160520"/>
+            <a:off x="6720840" y="4023360"/>
             <a:ext cx="4846320" cy="292608"/>
           </a:xfrm>
           <a:prstGeom prst="rect">
@@ -6504,7 +6582,7 @@
         </p:blipFill>
         <p:spPr>
           <a:xfrm>
-            <a:off x="6309360" y="4636008"/>
+            <a:off x="6309360" y="4498848"/>
             <a:ext cx="256032" cy="256032"/>
           </a:xfrm>
           <a:prstGeom prst="rect">
@@ -6520,7 +6598,7 @@
         </p:nvSpPr>
         <p:spPr>
           <a:xfrm>
-            <a:off x="6720840" y="4617720"/>
+            <a:off x="6720840" y="4480560"/>
             <a:ext cx="4846320" cy="292608"/>
           </a:xfrm>
           <a:prstGeom prst="rect">
@@ -6545,7 +6623,7 @@
                 <a:ea typeface="Outfit" pitchFamily="34" charset="-122"/>
                 <a:cs typeface="Outfit" pitchFamily="34" charset="-120"/>
               </a:rPr>
-              <a:t>Code: ev-registry/ in the fans-app repo</a:t>
+              <a:t>Company: syfr.live</a:t>
             </a:r>
             <a:endParaRPr lang="en-US" sz="1300" dirty="0"/>
           </a:p>
@@ -6567,7 +6645,7 @@
         </p:blipFill>
         <p:spPr>
           <a:xfrm>
-            <a:off x="6309360" y="5093208"/>
+            <a:off x="6309360" y="4956048"/>
             <a:ext cx="256032" cy="256032"/>
           </a:xfrm>
           <a:prstGeom prst="rect">
@@ -6583,7 +6661,70 @@
         </p:nvSpPr>
         <p:spPr>
           <a:xfrm>
-            <a:off x="6720840" y="5074920"/>
+            <a:off x="6720840" y="4937760"/>
+            <a:ext cx="4846320" cy="292608"/>
+          </a:xfrm>
+          <a:prstGeom prst="rect">
+            <a:avLst/>
+          </a:prstGeom>
+          <a:noFill/>
+          <a:ln/>
+        </p:spPr>
+        <p:txBody>
+          <a:bodyPr wrap="square" lIns="0" tIns="0" rIns="0" bIns="0" rtlCol="0" anchor="ctr"/>
+          <a:lstStyle/>
+          <a:p>
+            <a:pPr indent="0" marL="0">
+              <a:buNone/>
+            </a:pPr>
+            <a:r>
+              <a:rPr lang="en-US" sz="1300" dirty="0">
+                <a:solidFill>
+                  <a:schemeClr val="tx1"/>
+                </a:solidFill>
+                <a:latin typeface="Outfit" pitchFamily="34" charset="0"/>
+                <a:ea typeface="Outfit" pitchFamily="34" charset="-122"/>
+                <a:cs typeface="Outfit" pitchFamily="34" charset="-120"/>
+              </a:rPr>
+              <a:t>Code: ev-registry/ in the fans-app repo</a:t>
+            </a:r>
+            <a:endParaRPr lang="en-US" sz="1300" dirty="0"/>
+          </a:p>
+        </p:txBody>
+      </p:sp>
+      <p:pic>
+        <p:nvPicPr>
+          <p:cNvPr id="12" name="Icon 4" descr="Icon 4">    </p:cNvPr>
+          <p:cNvPicPr>
+            <a:picLocks noChangeAspect="1"/>
+          </p:cNvPicPr>
+          <p:nvPr/>
+        </p:nvPicPr>
+        <p:blipFill>
+          <a:blip r:embed="rId6"/>
+          <a:stretch>
+            <a:fillRect/>
+          </a:stretch>
+        </p:blipFill>
+        <p:spPr>
+          <a:xfrm>
+            <a:off x="6309360" y="5413248"/>
+            <a:ext cx="256032" cy="256032"/>
+          </a:xfrm>
+          <a:prstGeom prst="rect">
+            <a:avLst/>
+          </a:prstGeom>
+        </p:spPr>
+      </p:pic>
+      <p:sp>
+        <p:nvSpPr>
+          <p:cNvPr id="13" name="Contact 4"/>
+          <p:cNvSpPr txBox="1"/>
+          <p:nvPr/>
+        </p:nvSpPr>
+        <p:spPr>
+          <a:xfrm>
+            <a:off x="6720840" y="5394960"/>
             <a:ext cx="4846320" cy="292608"/>
           </a:xfrm>
           <a:prstGeom prst="rect">

</xml_diff>